<commit_message>
docs(lineage): Graft folded — the 42nd repository; README and deck counts follow
Co-Authored-By: Claude Fable 5.1 <noreply@anthropic.com>
</commit_message>
<xml_diff>
--- a/present/ripwire-showcase.pptx
+++ b/present/ripwire-showcase.pptx
@@ -23304,7 +23304,7 @@
                 <a:ea typeface="Arial" pitchFamily="34" charset="-122"/>
                 <a:cs typeface="Arial" pitchFamily="34" charset="-120"/>
               </a:rPr>
-              <a:t>41 repositories + 67 papers folded</a:t>
+              <a:t>42 repositories + 67 papers folded</a:t>
             </a:r>
             <a:pPr indent="0" marL="0">
               <a:buNone/>
@@ -25318,7 +25318,7 @@
                 <a:ea typeface="Arial" pitchFamily="34" charset="-122"/>
                 <a:cs typeface="Arial" pitchFamily="34" charset="-120"/>
               </a:rPr>
-              <a:t>41 repos · 67 papers · 237 surveyed</a:t>
+              <a:t>42 repos · 67 papers · 237 surveyed</a:t>
             </a:r>
             <a:endParaRPr lang="en-US" sz="1200" dirty="0"/>
           </a:p>

</xml_diff>